<commit_message>
Add About Frank slide + headshot to deck
</commit_message>
<xml_diff>
--- a/deck/week1-orientation.pptx
+++ b/deck/week1-orientation.pptx
@@ -27,6 +27,7 @@
     <p:sldId id="275" r:id="rId26"/>
     <p:sldId id="276" r:id="rId27"/>
     <p:sldId id="277" r:id="rId28"/>
+    <p:sldId id="278" r:id="rId29"/>
   </p:sldIdLst>
   <p:sldSz cx="12191695" cy="6858000" type="screen4x3"/>
   <p:notesSz cx="6858000" cy="9144000"/>
@@ -5545,6 +5546,220 @@
       <p:sp>
         <p:nvSpPr>
           <p:cNvPr id="4" name="TextBox 3"/>
+          <p:cNvSpPr txBox="1"/>
+          <p:nvPr/>
+        </p:nvSpPr>
+        <p:spPr>
+          <a:xfrm>
+            <a:off x="640080" y="6400800"/>
+            <a:ext cx="5486400" cy="365760"/>
+          </a:xfrm>
+          <a:prstGeom prst="rect">
+            <a:avLst/>
+          </a:prstGeom>
+          <a:noFill/>
+        </p:spPr>
+        <p:txBody>
+          <a:bodyPr wrap="none">
+            <a:spAutoFit/>
+          </a:bodyPr>
+          <a:lstStyle/>
+          <a:p>
+            <a:r>
+              <a:rPr sz="1200" b="1">
+                <a:solidFill>
+                  <a:srgbClr val="B38F4B"/>
+                </a:solidFill>
+              </a:rPr>
+              <a:t>AI LAB SERIES</a:t>
+            </a:r>
+          </a:p>
+        </p:txBody>
+      </p:sp>
+    </p:spTree>
+  </p:cSld>
+  <p:clrMapOvr>
+    <a:masterClrMapping/>
+  </p:clrMapOvr>
+</p:sld>
+</file>
+
+<file path=ppt/slides/slide23.xml><?xml version="1.0" encoding="utf-8"?>
+<p:sld xmlns:a="http://schemas.openxmlformats.org/drawingml/2006/main" xmlns:p="http://schemas.openxmlformats.org/presentationml/2006/main" xmlns:r="http://schemas.openxmlformats.org/officeDocument/2006/relationships">
+  <p:cSld>
+    <p:spTree>
+      <p:nvGrpSpPr>
+        <p:cNvPr id="1" name=""/>
+        <p:cNvGrpSpPr/>
+        <p:nvPr/>
+      </p:nvGrpSpPr>
+      <p:grpSpPr/>
+      <p:pic>
+        <p:nvPicPr>
+          <p:cNvPr id="2" name="Picture 1" descr="frank-headshot.png"/>
+          <p:cNvPicPr>
+            <a:picLocks noChangeAspect="1"/>
+          </p:cNvPicPr>
+          <p:nvPr/>
+        </p:nvPicPr>
+        <p:blipFill>
+          <a:blip r:embed="rId2"/>
+          <a:stretch>
+            <a:fillRect/>
+          </a:stretch>
+        </p:blipFill>
+        <p:spPr>
+          <a:xfrm>
+            <a:off x="822960" y="1463040"/>
+            <a:ext cx="3931920" cy="3931920"/>
+          </a:xfrm>
+          <a:prstGeom prst="rect">
+            <a:avLst/>
+          </a:prstGeom>
+        </p:spPr>
+      </p:pic>
+      <p:sp>
+        <p:nvSpPr>
+          <p:cNvPr id="3" name="TextBox 2"/>
+          <p:cNvSpPr txBox="1"/>
+          <p:nvPr/>
+        </p:nvSpPr>
+        <p:spPr>
+          <a:xfrm>
+            <a:off x="5303520" y="1554480"/>
+            <a:ext cx="6217920" cy="914400"/>
+          </a:xfrm>
+          <a:prstGeom prst="rect">
+            <a:avLst/>
+          </a:prstGeom>
+          <a:noFill/>
+        </p:spPr>
+        <p:txBody>
+          <a:bodyPr wrap="none">
+            <a:spAutoFit/>
+          </a:bodyPr>
+          <a:lstStyle/>
+          <a:p>
+            <a:r>
+              <a:rPr sz="4000" b="1">
+                <a:solidFill>
+                  <a:srgbClr val="1B2A4A"/>
+                </a:solidFill>
+              </a:rPr>
+              <a:t>Frank Martinez</a:t>
+            </a:r>
+          </a:p>
+        </p:txBody>
+      </p:sp>
+      <p:sp>
+        <p:nvSpPr>
+          <p:cNvPr id="4" name="TextBox 3"/>
+          <p:cNvSpPr txBox="1"/>
+          <p:nvPr/>
+        </p:nvSpPr>
+        <p:spPr>
+          <a:xfrm>
+            <a:off x="5303520" y="2377440"/>
+            <a:ext cx="6217920" cy="548640"/>
+          </a:xfrm>
+          <a:prstGeom prst="rect">
+            <a:avLst/>
+          </a:prstGeom>
+          <a:noFill/>
+        </p:spPr>
+        <p:txBody>
+          <a:bodyPr wrap="none">
+            <a:spAutoFit/>
+          </a:bodyPr>
+          <a:lstStyle/>
+          <a:p>
+            <a:r>
+              <a:rPr sz="2000" i="1">
+                <a:solidFill>
+                  <a:srgbClr val="B38F4B"/>
+                </a:solidFill>
+              </a:rPr>
+              <a:t>Instructor, INFO 492 C — Construction Informatics</a:t>
+            </a:r>
+          </a:p>
+        </p:txBody>
+      </p:sp>
+      <p:sp>
+        <p:nvSpPr>
+          <p:cNvPr id="5" name="TextBox 4"/>
+          <p:cNvSpPr txBox="1"/>
+          <p:nvPr/>
+        </p:nvSpPr>
+        <p:spPr>
+          <a:xfrm>
+            <a:off x="5303520" y="3017520"/>
+            <a:ext cx="6217920" cy="3108960"/>
+          </a:xfrm>
+          <a:prstGeom prst="rect">
+            <a:avLst/>
+          </a:prstGeom>
+          <a:noFill/>
+        </p:spPr>
+        <p:txBody>
+          <a:bodyPr wrap="square">
+            <a:spAutoFit/>
+          </a:bodyPr>
+          <a:lstStyle/>
+          <a:p>
+            <a:r>
+              <a:rPr sz="1700">
+                <a:solidFill>
+                  <a:srgbClr val="444444"/>
+                </a:solidFill>
+              </a:rPr>
+              <a:t>•  Lecturer, UW Information School — AI LAB series</a:t>
+            </a:r>
+          </a:p>
+          <a:p>
+            <a:r>
+              <a:rPr sz="1700">
+                <a:solidFill>
+                  <a:srgbClr val="444444"/>
+                </a:solidFill>
+              </a:rPr>
+              <a:t>•  Founder, Last Myle Engineering — applied AI and data systems</a:t>
+            </a:r>
+          </a:p>
+          <a:p>
+            <a:r>
+              <a:rPr sz="1700">
+                <a:solidFill>
+                  <a:srgbClr val="444444"/>
+                </a:solidFill>
+              </a:rPr>
+              <a:t>•  Co-founder, ¡Adiós COVID! (2020–24) — public-health informatics with WA DOH / VACCS Center</a:t>
+            </a:r>
+          </a:p>
+          <a:p>
+            <a:r>
+              <a:rPr sz="1700">
+                <a:solidFill>
+                  <a:srgbClr val="444444"/>
+                </a:solidFill>
+              </a:rPr>
+              <a:t>•  Builds with AI agents, LLMs, and agentic systems across regulated industries</a:t>
+            </a:r>
+          </a:p>
+          <a:p>
+            <a:r>
+              <a:rPr sz="1700">
+                <a:solidFill>
+                  <a:srgbClr val="444444"/>
+                </a:solidFill>
+              </a:rPr>
+              <a:t>•  Focus: how information flows (and breaks) in high-stakes, multi-party environments</a:t>
+            </a:r>
+          </a:p>
+        </p:txBody>
+      </p:sp>
+      <p:sp>
+        <p:nvSpPr>
+          <p:cNvPr id="6" name="TextBox 5"/>
           <p:cNvSpPr txBox="1"/>
           <p:nvPr/>
         </p:nvSpPr>

</xml_diff>